<commit_message>
Folien aktualisiert und doppelte file gelöscht
</commit_message>
<xml_diff>
--- a/presentation/Hauskauf_Seattle.pptx
+++ b/presentation/Hauskauf_Seattle.pptx
@@ -7146,13 +7146,22 @@
               <a:t>Femont</a:t>
             </a:r>
             <a:r>
+              <a:rPr lang="de-DE" sz="1400" b="0" i="0">
+                <a:solidFill>
+                  <a:srgbClr val="1B2A2F"/>
+                </a:solidFill>
+                <a:latin typeface="Calibri"/>
+              </a:rPr>
+              <a:t>, </a:t>
+            </a:r>
+            <a:r>
               <a:rPr lang="de-DE" sz="1400" b="0" i="0" dirty="0">
                 <a:solidFill>
                   <a:srgbClr val="1B2A2F"/>
                 </a:solidFill>
                 <a:latin typeface="Calibri"/>
               </a:rPr>
-              <a:t> Ballard</a:t>
+              <a:t>Ballard</a:t>
             </a:r>
           </a:p>
           <a:p>
@@ -8786,7 +8795,25 @@
                 </a:solidFill>
                 <a:latin typeface="Calibri"/>
               </a:rPr>
-              <a:t> 625.000 </a:t>
+              <a:t> 6</a:t>
+            </a:r>
+            <a:r>
+              <a:rPr lang="de-DE" sz="1600" b="0" i="0" dirty="0">
+                <a:solidFill>
+                  <a:srgbClr val="1B2A2F"/>
+                </a:solidFill>
+                <a:latin typeface="Calibri"/>
+              </a:rPr>
+              <a:t>30</a:t>
+            </a:r>
+            <a:r>
+              <a:rPr sz="1600" b="0" i="0" dirty="0">
+                <a:solidFill>
+                  <a:srgbClr val="1B2A2F"/>
+                </a:solidFill>
+                <a:latin typeface="Calibri"/>
+              </a:rPr>
+              <a:t>.000 </a:t>
             </a:r>
             <a:r>
               <a:rPr sz="1600" b="0" i="0" dirty="0" err="1">

</xml_diff>